<commit_message>
Updates W15 S7 Proyecto Colaborativo
</commit_message>
<xml_diff>
--- a/04-data-wrangling/07-data-wrangling.pptx
+++ b/04-data-wrangling/07-data-wrangling.pptx
@@ -14,22 +14,22 @@
     <p:sldId id="262" r:id="rId9"/>
   </p:sldIdLst>
   <p:sldSz cx="9144000" cy="5143500"/>
-  <p:notesSz cx="6858000" cy="9144000"/>
+  <p:notesSz cx="7772400" cy="10058400"/>
   <p:embeddedFontLst>
     <p:embeddedFont>
-      <p:font typeface="Inter SemiBold"/>
+      <p:font typeface="Inter Medium"/>
     </p:embeddedFont>
     <p:embeddedFont>
-      <p:font typeface="Inter Medium"/>
+      <p:font typeface="Inter ExtraBold"/>
+    </p:embeddedFont>
+    <p:embeddedFont>
+      <p:font typeface="Inter SemiBold"/>
     </p:embeddedFont>
     <p:embeddedFont>
       <p:font typeface="Inter"/>
       <p:bold r:id="rId10"/>
       <p:italic r:id="rId11"/>
       <p:boldItalic r:id="rId12"/>
-    </p:embeddedFont>
-    <p:embeddedFont>
-      <p:font typeface="Inter ExtraBold"/>
     </p:embeddedFont>
     <p:embeddedFont>
       <p:font typeface="Microsoft YaHei"/>
@@ -42,8 +42,8 @@
 </file>
 
 <file path=ppt/slideLayouts/slideLayout1.xml><?xml version="1.0" encoding="utf-8"?>
-<p:sldLayout xmlns:a="http://schemas.openxmlformats.org/drawingml/2006/main" xmlns:p="http://schemas.openxmlformats.org/presentationml/2006/main" xmlns:r="http://schemas.openxmlformats.org/officeDocument/2006/relationships" xmlns:p14="http://schemas.microsoft.com/office/powerpoint/2010/main" xmlns:p15="http://schemas.microsoft.com/office/powerpoint/2012/main" xmlns:mc="http://schemas.openxmlformats.org/markup-compatibility/2006" type="title" preserve="1">
-  <p:cSld name="TITLE">
+<p:sldLayout xmlns:a="http://schemas.openxmlformats.org/drawingml/2006/main" xmlns:p="http://schemas.openxmlformats.org/presentationml/2006/main" xmlns:r="http://schemas.openxmlformats.org/officeDocument/2006/relationships" xmlns:p14="http://schemas.microsoft.com/office/powerpoint/2010/main" xmlns:p15="http://schemas.microsoft.com/office/powerpoint/2012/main" xmlns:mc="http://schemas.openxmlformats.org/markup-compatibility/2006" type="blank" preserve="1">
+  <p:cSld name="ONE_COLUMN_TEXT">
     <p:bg>
       <p:bgPr>
         <a:solidFill>
@@ -78,7 +78,7 @@
         <p:spPr>
           <a:xfrm>
             <a:off x="8472600" y="4663080"/>
-            <a:ext cx="548280" cy="393120"/>
+            <a:ext cx="547920" cy="392760"/>
           </a:xfrm>
           <a:prstGeom prst="rect">
             <a:avLst/>
@@ -122,7 +122,7 @@
                 <a:tab algn="l" pos="0"/>
               </a:tabLst>
             </a:pPr>
-            <a:fld id="{2D440932-63A2-4353-B30E-1D17287FB54A}" type="slidenum">
+            <a:fld id="{C54FC52A-231E-43D6-9AFA-98C0723C101F}" type="slidenum">
               <a:rPr b="0" lang="en" sz="1000" strike="noStrike" u="none">
                 <a:solidFill>
                   <a:schemeClr val="dk2"/>
@@ -141,312 +141,6 @@
               <a:effectLst/>
               <a:uFillTx/>
               <a:latin typeface="Times New Roman"/>
-            </a:endParaRPr>
-          </a:p>
-        </p:txBody>
-      </p:sp>
-      <p:sp>
-        <p:nvSpPr>
-          <p:cNvPr id="3" name="PlaceHolder 2"/>
-          <p:cNvSpPr>
-            <a:spLocks noGrp="1"/>
-          </p:cNvSpPr>
-          <p:nvPr>
-            <p:ph type="title"/>
-          </p:nvPr>
-        </p:nvSpPr>
-        <p:spPr>
-          <a:xfrm>
-            <a:off x="457200" y="205200"/>
-            <a:ext cx="8229240" cy="858600"/>
-          </a:xfrm>
-          <a:prstGeom prst="rect">
-            <a:avLst/>
-          </a:prstGeom>
-          <a:noFill/>
-          <a:ln w="0">
-            <a:noFill/>
-          </a:ln>
-        </p:spPr>
-        <p:txBody>
-          <a:bodyPr lIns="0" rIns="0" tIns="0" bIns="0" anchor="ctr">
-            <a:noAutofit/>
-          </a:bodyPr>
-          <a:p>
-            <a:pPr indent="0">
-              <a:buNone/>
-            </a:pPr>
-            <a:r>
-              <a:rPr b="0" lang="es-MX" sz="1400" strike="noStrike" u="none">
-                <a:solidFill>
-                  <a:srgbClr val="000000"/>
-                </a:solidFill>
-                <a:effectLst/>
-                <a:uFillTx/>
-                <a:latin typeface="Arial"/>
-              </a:rPr>
-              <a:t>Pulse para editar el formato del texto de título</a:t>
-            </a:r>
-            <a:endParaRPr b="0" lang="es-MX" sz="1400" strike="noStrike" u="none">
-              <a:solidFill>
-                <a:srgbClr val="000000"/>
-              </a:solidFill>
-              <a:effectLst/>
-              <a:uFillTx/>
-              <a:latin typeface="Arial"/>
-            </a:endParaRPr>
-          </a:p>
-        </p:txBody>
-      </p:sp>
-      <p:sp>
-        <p:nvSpPr>
-          <p:cNvPr id="4" name="PlaceHolder 3"/>
-          <p:cNvSpPr>
-            <a:spLocks noGrp="1"/>
-          </p:cNvSpPr>
-          <p:nvPr>
-            <p:ph type="body"/>
-          </p:nvPr>
-        </p:nvSpPr>
-        <p:spPr>
-          <a:xfrm>
-            <a:off x="457200" y="1203480"/>
-            <a:ext cx="8229240" cy="2982960"/>
-          </a:xfrm>
-          <a:prstGeom prst="rect">
-            <a:avLst/>
-          </a:prstGeom>
-          <a:noFill/>
-          <a:ln w="0">
-            <a:noFill/>
-          </a:ln>
-        </p:spPr>
-        <p:txBody>
-          <a:bodyPr lIns="0" rIns="0" tIns="0" bIns="0" anchor="t">
-            <a:normAutofit/>
-          </a:bodyPr>
-          <a:p>
-            <a:pPr marL="432000" indent="-324000">
-              <a:spcBef>
-                <a:spcPts val="1417"/>
-              </a:spcBef>
-              <a:buClr>
-                <a:srgbClr val="000000"/>
-              </a:buClr>
-              <a:buSzPct val="45000"/>
-              <a:buFont typeface="Wingdings" charset="2"/>
-              <a:buChar char=""/>
-            </a:pPr>
-            <a:r>
-              <a:rPr b="0" lang="es-MX" sz="1400" strike="noStrike" u="none">
-                <a:solidFill>
-                  <a:srgbClr val="000000"/>
-                </a:solidFill>
-                <a:effectLst/>
-                <a:uFillTx/>
-                <a:latin typeface="Arial"/>
-              </a:rPr>
-              <a:t>Pulse para editar el formato de texto del esquema</a:t>
-            </a:r>
-            <a:endParaRPr b="0" lang="es-MX" sz="1400" strike="noStrike" u="none">
-              <a:solidFill>
-                <a:srgbClr val="000000"/>
-              </a:solidFill>
-              <a:effectLst/>
-              <a:uFillTx/>
-              <a:latin typeface="Arial"/>
-            </a:endParaRPr>
-          </a:p>
-          <a:p>
-            <a:pPr lvl="1" marL="864000" indent="-324000">
-              <a:spcBef>
-                <a:spcPts val="1134"/>
-              </a:spcBef>
-              <a:buClr>
-                <a:srgbClr val="000000"/>
-              </a:buClr>
-              <a:buSzPct val="75000"/>
-              <a:buFont typeface="Symbol" charset="2"/>
-              <a:buChar char=""/>
-            </a:pPr>
-            <a:r>
-              <a:rPr b="0" lang="es-MX" sz="1400" strike="noStrike" u="none">
-                <a:solidFill>
-                  <a:srgbClr val="000000"/>
-                </a:solidFill>
-                <a:effectLst/>
-                <a:uFillTx/>
-                <a:latin typeface="Arial"/>
-              </a:rPr>
-              <a:t>Segundo nivel del esquema</a:t>
-            </a:r>
-            <a:endParaRPr b="0" lang="es-MX" sz="1400" strike="noStrike" u="none">
-              <a:solidFill>
-                <a:srgbClr val="000000"/>
-              </a:solidFill>
-              <a:effectLst/>
-              <a:uFillTx/>
-              <a:latin typeface="Arial"/>
-            </a:endParaRPr>
-          </a:p>
-          <a:p>
-            <a:pPr lvl="2" marL="1296000" indent="-288000">
-              <a:spcBef>
-                <a:spcPts val="850"/>
-              </a:spcBef>
-              <a:buClr>
-                <a:srgbClr val="000000"/>
-              </a:buClr>
-              <a:buSzPct val="45000"/>
-              <a:buFont typeface="Wingdings" charset="2"/>
-              <a:buChar char=""/>
-            </a:pPr>
-            <a:r>
-              <a:rPr b="0" lang="es-MX" sz="1400" strike="noStrike" u="none">
-                <a:solidFill>
-                  <a:srgbClr val="000000"/>
-                </a:solidFill>
-                <a:effectLst/>
-                <a:uFillTx/>
-                <a:latin typeface="Arial"/>
-              </a:rPr>
-              <a:t>Tercer nivel del esquema</a:t>
-            </a:r>
-            <a:endParaRPr b="0" lang="es-MX" sz="1400" strike="noStrike" u="none">
-              <a:solidFill>
-                <a:srgbClr val="000000"/>
-              </a:solidFill>
-              <a:effectLst/>
-              <a:uFillTx/>
-              <a:latin typeface="Arial"/>
-            </a:endParaRPr>
-          </a:p>
-          <a:p>
-            <a:pPr lvl="3" marL="1728000" indent="-216000">
-              <a:spcBef>
-                <a:spcPts val="567"/>
-              </a:spcBef>
-              <a:buClr>
-                <a:srgbClr val="000000"/>
-              </a:buClr>
-              <a:buSzPct val="75000"/>
-              <a:buFont typeface="Symbol" charset="2"/>
-              <a:buChar char=""/>
-            </a:pPr>
-            <a:r>
-              <a:rPr b="0" lang="es-MX" sz="1400" strike="noStrike" u="none">
-                <a:solidFill>
-                  <a:srgbClr val="000000"/>
-                </a:solidFill>
-                <a:effectLst/>
-                <a:uFillTx/>
-                <a:latin typeface="Arial"/>
-              </a:rPr>
-              <a:t>Cuarto nivel del esquema</a:t>
-            </a:r>
-            <a:endParaRPr b="0" lang="es-MX" sz="1400" strike="noStrike" u="none">
-              <a:solidFill>
-                <a:srgbClr val="000000"/>
-              </a:solidFill>
-              <a:effectLst/>
-              <a:uFillTx/>
-              <a:latin typeface="Arial"/>
-            </a:endParaRPr>
-          </a:p>
-          <a:p>
-            <a:pPr lvl="4" marL="2160000" indent="-216000">
-              <a:spcBef>
-                <a:spcPts val="283"/>
-              </a:spcBef>
-              <a:buClr>
-                <a:srgbClr val="000000"/>
-              </a:buClr>
-              <a:buSzPct val="45000"/>
-              <a:buFont typeface="Wingdings" charset="2"/>
-              <a:buChar char=""/>
-            </a:pPr>
-            <a:r>
-              <a:rPr b="0" lang="es-MX" sz="2000" strike="noStrike" u="none">
-                <a:solidFill>
-                  <a:srgbClr val="000000"/>
-                </a:solidFill>
-                <a:effectLst/>
-                <a:uFillTx/>
-                <a:latin typeface="Arial"/>
-              </a:rPr>
-              <a:t>Quinto nivel del esquema</a:t>
-            </a:r>
-            <a:endParaRPr b="0" lang="es-MX" sz="2000" strike="noStrike" u="none">
-              <a:solidFill>
-                <a:srgbClr val="000000"/>
-              </a:solidFill>
-              <a:effectLst/>
-              <a:uFillTx/>
-              <a:latin typeface="Arial"/>
-            </a:endParaRPr>
-          </a:p>
-          <a:p>
-            <a:pPr lvl="5" marL="2592000" indent="-216000">
-              <a:spcBef>
-                <a:spcPts val="283"/>
-              </a:spcBef>
-              <a:buClr>
-                <a:srgbClr val="000000"/>
-              </a:buClr>
-              <a:buSzPct val="45000"/>
-              <a:buFont typeface="Wingdings" charset="2"/>
-              <a:buChar char=""/>
-            </a:pPr>
-            <a:r>
-              <a:rPr b="0" lang="es-MX" sz="2000" strike="noStrike" u="none">
-                <a:solidFill>
-                  <a:srgbClr val="000000"/>
-                </a:solidFill>
-                <a:effectLst/>
-                <a:uFillTx/>
-                <a:latin typeface="Arial"/>
-              </a:rPr>
-              <a:t>Sexto nivel del esquema</a:t>
-            </a:r>
-            <a:endParaRPr b="0" lang="es-MX" sz="2000" strike="noStrike" u="none">
-              <a:solidFill>
-                <a:srgbClr val="000000"/>
-              </a:solidFill>
-              <a:effectLst/>
-              <a:uFillTx/>
-              <a:latin typeface="Arial"/>
-            </a:endParaRPr>
-          </a:p>
-          <a:p>
-            <a:pPr lvl="6" marL="3024000" indent="-216000">
-              <a:spcBef>
-                <a:spcPts val="283"/>
-              </a:spcBef>
-              <a:buClr>
-                <a:srgbClr val="000000"/>
-              </a:buClr>
-              <a:buSzPct val="45000"/>
-              <a:buFont typeface="Wingdings" charset="2"/>
-              <a:buChar char=""/>
-            </a:pPr>
-            <a:r>
-              <a:rPr b="0" lang="es-MX" sz="2000" strike="noStrike" u="none">
-                <a:solidFill>
-                  <a:srgbClr val="000000"/>
-                </a:solidFill>
-                <a:effectLst/>
-                <a:uFillTx/>
-                <a:latin typeface="Arial"/>
-              </a:rPr>
-              <a:t>Séptimo nivel del esquema</a:t>
-            </a:r>
-            <a:endParaRPr b="0" lang="es-MX" sz="2000" strike="noStrike" u="none">
-              <a:solidFill>
-                <a:srgbClr val="000000"/>
-              </a:solidFill>
-              <a:effectLst/>
-              <a:uFillTx/>
-              <a:latin typeface="Arial"/>
             </a:endParaRPr>
           </a:p>
         </p:txBody>
@@ -457,8 +151,8 @@
 </file>
 
 <file path=ppt/slideLayouts/slideLayout10.xml><?xml version="1.0" encoding="utf-8"?>
-<p:sldLayout xmlns:a="http://schemas.openxmlformats.org/drawingml/2006/main" xmlns:p="http://schemas.openxmlformats.org/presentationml/2006/main" xmlns:r="http://schemas.openxmlformats.org/officeDocument/2006/relationships" xmlns:p14="http://schemas.microsoft.com/office/powerpoint/2010/main" xmlns:p15="http://schemas.microsoft.com/office/powerpoint/2012/main" xmlns:mc="http://schemas.openxmlformats.org/markup-compatibility/2006" type="blank" preserve="1">
-  <p:cSld name="MAIN_POINT">
+<p:sldLayout xmlns:a="http://schemas.openxmlformats.org/drawingml/2006/main" xmlns:p="http://schemas.openxmlformats.org/presentationml/2006/main" xmlns:r="http://schemas.openxmlformats.org/officeDocument/2006/relationships" xmlns:p14="http://schemas.microsoft.com/office/powerpoint/2010/main" xmlns:p15="http://schemas.microsoft.com/office/powerpoint/2012/main" xmlns:mc="http://schemas.openxmlformats.org/markup-compatibility/2006" type="tx" preserve="1">
+  <p:cSld name="TITLE_AND_BODY">
     <p:bg>
       <p:bgPr>
         <a:solidFill>
@@ -493,7 +187,7 @@
         <p:spPr>
           <a:xfrm>
             <a:off x="8472600" y="4663080"/>
-            <a:ext cx="548280" cy="393120"/>
+            <a:ext cx="547920" cy="392760"/>
           </a:xfrm>
           <a:prstGeom prst="rect">
             <a:avLst/>
@@ -537,7 +231,7 @@
                 <a:tab algn="l" pos="0"/>
               </a:tabLst>
             </a:pPr>
-            <a:fld id="{245D3E1E-A116-48B8-8958-A05BA8DDD492}" type="slidenum">
+            <a:fld id="{55A22E6C-9447-404B-A297-4F752197BAD6}" type="slidenum">
               <a:rPr b="0" lang="en" sz="1000" strike="noStrike" u="none">
                 <a:solidFill>
                   <a:schemeClr val="dk2"/>
@@ -566,8 +260,8 @@
 </file>
 
 <file path=ppt/slideLayouts/slideLayout11.xml><?xml version="1.0" encoding="utf-8"?>
-<p:sldLayout xmlns:a="http://schemas.openxmlformats.org/drawingml/2006/main" xmlns:p="http://schemas.openxmlformats.org/presentationml/2006/main" xmlns:r="http://schemas.openxmlformats.org/officeDocument/2006/relationships" xmlns:p14="http://schemas.microsoft.com/office/powerpoint/2010/main" xmlns:p15="http://schemas.microsoft.com/office/powerpoint/2012/main" xmlns:mc="http://schemas.openxmlformats.org/markup-compatibility/2006" type="blank" preserve="1">
-  <p:cSld name="SECTION_TITLE_AND_DESCRIPTION">
+<p:sldLayout xmlns:a="http://schemas.openxmlformats.org/drawingml/2006/main" xmlns:p="http://schemas.openxmlformats.org/presentationml/2006/main" xmlns:r="http://schemas.openxmlformats.org/officeDocument/2006/relationships" xmlns:p14="http://schemas.microsoft.com/office/powerpoint/2010/main" xmlns:p15="http://schemas.microsoft.com/office/powerpoint/2012/main" xmlns:mc="http://schemas.openxmlformats.org/markup-compatibility/2006" type="twoObj" preserve="1">
+  <p:cSld name="TITLE_AND_TWO_COLUMNS">
     <p:bg>
       <p:bgPr>
         <a:solidFill>
@@ -602,7 +296,7 @@
         <p:spPr>
           <a:xfrm>
             <a:off x="8472600" y="4663080"/>
-            <a:ext cx="548280" cy="393120"/>
+            <a:ext cx="547920" cy="392760"/>
           </a:xfrm>
           <a:prstGeom prst="rect">
             <a:avLst/>
@@ -646,7 +340,7 @@
                 <a:tab algn="l" pos="0"/>
               </a:tabLst>
             </a:pPr>
-            <a:fld id="{CDCDC346-509A-4088-9AE5-8FB37FBAC458}" type="slidenum">
+            <a:fld id="{04ED8709-4F9D-4C41-9347-AB1D3711DD4F}" type="slidenum">
               <a:rPr b="0" lang="en" sz="1000" strike="noStrike" u="none">
                 <a:solidFill>
                   <a:schemeClr val="dk2"/>
@@ -675,8 +369,8 @@
 </file>
 
 <file path=ppt/slideLayouts/slideLayout12.xml><?xml version="1.0" encoding="utf-8"?>
-<p:sldLayout xmlns:a="http://schemas.openxmlformats.org/drawingml/2006/main" xmlns:p="http://schemas.openxmlformats.org/presentationml/2006/main" xmlns:r="http://schemas.openxmlformats.org/officeDocument/2006/relationships" xmlns:p14="http://schemas.microsoft.com/office/powerpoint/2010/main" xmlns:p15="http://schemas.microsoft.com/office/powerpoint/2012/main" xmlns:mc="http://schemas.openxmlformats.org/markup-compatibility/2006" type="blank" preserve="1">
-  <p:cSld name="CAPTION_ONLY">
+<p:sldLayout xmlns:a="http://schemas.openxmlformats.org/drawingml/2006/main" xmlns:p="http://schemas.openxmlformats.org/presentationml/2006/main" xmlns:r="http://schemas.openxmlformats.org/officeDocument/2006/relationships" xmlns:p14="http://schemas.microsoft.com/office/powerpoint/2010/main" xmlns:p15="http://schemas.microsoft.com/office/powerpoint/2012/main" xmlns:mc="http://schemas.openxmlformats.org/markup-compatibility/2006" type="titleOnly" preserve="1">
+  <p:cSld name="TITLE_ONLY">
     <p:bg>
       <p:bgPr>
         <a:solidFill>
@@ -711,7 +405,7 @@
         <p:spPr>
           <a:xfrm>
             <a:off x="8472600" y="4663080"/>
-            <a:ext cx="548280" cy="393120"/>
+            <a:ext cx="547920" cy="392760"/>
           </a:xfrm>
           <a:prstGeom prst="rect">
             <a:avLst/>
@@ -723,12 +417,50 @@
         </p:spPr>
         <p:txBody>
           <a:bodyPr lIns="91440" rIns="91440" tIns="91440" bIns="91440" anchor="ctr">
-            <a:normAutofit fontScale="55000" lnSpcReduction="19999"/>
+            <a:normAutofit/>
           </a:bodyPr>
-          <a:p>
-            <a:pPr indent="0">
+          <a:lstStyle>
+            <a:lvl1pPr indent="0" algn="r">
+              <a:lnSpc>
+                <a:spcPct val="100000"/>
+              </a:lnSpc>
               <a:buNone/>
-            </a:pPr>
+              <a:tabLst>
+                <a:tab algn="l" pos="0"/>
+              </a:tabLst>
+              <a:defRPr b="0" lang="en" sz="1000" strike="noStrike" u="none">
+                <a:solidFill>
+                  <a:schemeClr val="dk2"/>
+                </a:solidFill>
+                <a:effectLst/>
+                <a:uFillTx/>
+                <a:latin typeface="Arial"/>
+                <a:ea typeface="Arial"/>
+              </a:defRPr>
+            </a:lvl1pPr>
+          </a:lstStyle>
+          <a:p>
+            <a:pPr indent="0" algn="r">
+              <a:lnSpc>
+                <a:spcPct val="100000"/>
+              </a:lnSpc>
+              <a:buNone/>
+              <a:tabLst>
+                <a:tab algn="l" pos="0"/>
+              </a:tabLst>
+            </a:pPr>
+            <a:fld id="{BCEFC0B8-CD74-4D1A-A3FD-B413830D72CF}" type="slidenum">
+              <a:rPr b="0" lang="en" sz="1000" strike="noStrike" u="none">
+                <a:solidFill>
+                  <a:schemeClr val="dk2"/>
+                </a:solidFill>
+                <a:effectLst/>
+                <a:uFillTx/>
+                <a:latin typeface="Arial"/>
+                <a:ea typeface="Arial"/>
+              </a:rPr>
+              <a:t>&lt;número&gt;</a:t>
+            </a:fld>
             <a:endParaRPr b="0" lang="es-MX" sz="1000" strike="noStrike" u="none">
               <a:solidFill>
                 <a:srgbClr val="000000"/>
@@ -747,7 +479,225 @@
 
 <file path=ppt/slideLayouts/slideLayout2.xml><?xml version="1.0" encoding="utf-8"?>
 <p:sldLayout xmlns:a="http://schemas.openxmlformats.org/drawingml/2006/main" xmlns:p="http://schemas.openxmlformats.org/presentationml/2006/main" xmlns:r="http://schemas.openxmlformats.org/officeDocument/2006/relationships" xmlns:p14="http://schemas.microsoft.com/office/powerpoint/2010/main" xmlns:p15="http://schemas.microsoft.com/office/powerpoint/2012/main" xmlns:mc="http://schemas.openxmlformats.org/markup-compatibility/2006" type="blank" preserve="1">
-  <p:cSld name="BIG_NUMBER">
+  <p:cSld name="MAIN_POINT">
+    <p:bg>
+      <p:bgPr>
+        <a:solidFill>
+          <a:schemeClr val="lt1"/>
+        </a:solidFill>
+      </p:bgPr>
+    </p:bg>
+    <p:spTree>
+      <p:nvGrpSpPr>
+        <p:cNvPr id="1" name=""/>
+        <p:cNvGrpSpPr/>
+        <p:nvPr/>
+      </p:nvGrpSpPr>
+      <p:grpSpPr>
+        <a:xfrm>
+          <a:off x="0" y="0"/>
+          <a:ext cx="0" cy="0"/>
+          <a:chOff x="0" y="0"/>
+          <a:chExt cx="0" cy="0"/>
+        </a:xfrm>
+      </p:grpSpPr>
+      <p:sp>
+        <p:nvSpPr>
+          <p:cNvPr id="3" name="PlaceHolder 1"/>
+          <p:cNvSpPr>
+            <a:spLocks noGrp="1"/>
+          </p:cNvSpPr>
+          <p:nvPr>
+            <p:ph type="sldNum" idx="2"/>
+          </p:nvPr>
+        </p:nvSpPr>
+        <p:spPr>
+          <a:xfrm>
+            <a:off x="8472600" y="4663080"/>
+            <a:ext cx="547920" cy="392760"/>
+          </a:xfrm>
+          <a:prstGeom prst="rect">
+            <a:avLst/>
+          </a:prstGeom>
+          <a:noFill/>
+          <a:ln w="0">
+            <a:noFill/>
+          </a:ln>
+        </p:spPr>
+        <p:txBody>
+          <a:bodyPr lIns="91440" rIns="91440" tIns="91440" bIns="91440" anchor="ctr">
+            <a:normAutofit/>
+          </a:bodyPr>
+          <a:lstStyle>
+            <a:lvl1pPr indent="0" algn="r">
+              <a:lnSpc>
+                <a:spcPct val="100000"/>
+              </a:lnSpc>
+              <a:buNone/>
+              <a:tabLst>
+                <a:tab algn="l" pos="0"/>
+              </a:tabLst>
+              <a:defRPr b="0" lang="en" sz="1000" strike="noStrike" u="none">
+                <a:solidFill>
+                  <a:schemeClr val="dk2"/>
+                </a:solidFill>
+                <a:effectLst/>
+                <a:uFillTx/>
+                <a:latin typeface="Arial"/>
+                <a:ea typeface="Arial"/>
+              </a:defRPr>
+            </a:lvl1pPr>
+          </a:lstStyle>
+          <a:p>
+            <a:pPr indent="0" algn="r">
+              <a:lnSpc>
+                <a:spcPct val="100000"/>
+              </a:lnSpc>
+              <a:buNone/>
+              <a:tabLst>
+                <a:tab algn="l" pos="0"/>
+              </a:tabLst>
+            </a:pPr>
+            <a:fld id="{FB48755F-A263-4A0F-9AB2-DA212D8F590C}" type="slidenum">
+              <a:rPr b="0" lang="en" sz="1000" strike="noStrike" u="none">
+                <a:solidFill>
+                  <a:schemeClr val="dk2"/>
+                </a:solidFill>
+                <a:effectLst/>
+                <a:uFillTx/>
+                <a:latin typeface="Arial"/>
+                <a:ea typeface="Arial"/>
+              </a:rPr>
+              <a:t>&lt;número&gt;</a:t>
+            </a:fld>
+            <a:endParaRPr b="0" lang="es-MX" sz="1000" strike="noStrike" u="none">
+              <a:solidFill>
+                <a:srgbClr val="000000"/>
+              </a:solidFill>
+              <a:effectLst/>
+              <a:uFillTx/>
+              <a:latin typeface="Times New Roman"/>
+            </a:endParaRPr>
+          </a:p>
+        </p:txBody>
+      </p:sp>
+    </p:spTree>
+  </p:cSld>
+</p:sldLayout>
+</file>
+
+<file path=ppt/slideLayouts/slideLayout3.xml><?xml version="1.0" encoding="utf-8"?>
+<p:sldLayout xmlns:a="http://schemas.openxmlformats.org/drawingml/2006/main" xmlns:p="http://schemas.openxmlformats.org/presentationml/2006/main" xmlns:r="http://schemas.openxmlformats.org/officeDocument/2006/relationships" xmlns:p14="http://schemas.microsoft.com/office/powerpoint/2010/main" xmlns:p15="http://schemas.microsoft.com/office/powerpoint/2012/main" xmlns:mc="http://schemas.openxmlformats.org/markup-compatibility/2006" type="blank" preserve="1">
+  <p:cSld name="SECTION_TITLE_AND_DESCRIPTION">
+    <p:bg>
+      <p:bgPr>
+        <a:solidFill>
+          <a:schemeClr val="lt1"/>
+        </a:solidFill>
+      </p:bgPr>
+    </p:bg>
+    <p:spTree>
+      <p:nvGrpSpPr>
+        <p:cNvPr id="1" name=""/>
+        <p:cNvGrpSpPr/>
+        <p:nvPr/>
+      </p:nvGrpSpPr>
+      <p:grpSpPr>
+        <a:xfrm>
+          <a:off x="0" y="0"/>
+          <a:ext cx="0" cy="0"/>
+          <a:chOff x="0" y="0"/>
+          <a:chExt cx="0" cy="0"/>
+        </a:xfrm>
+      </p:grpSpPr>
+      <p:sp>
+        <p:nvSpPr>
+          <p:cNvPr id="4" name="PlaceHolder 1"/>
+          <p:cNvSpPr>
+            <a:spLocks noGrp="1"/>
+          </p:cNvSpPr>
+          <p:nvPr>
+            <p:ph type="sldNum" idx="3"/>
+          </p:nvPr>
+        </p:nvSpPr>
+        <p:spPr>
+          <a:xfrm>
+            <a:off x="8472600" y="4663080"/>
+            <a:ext cx="547920" cy="392760"/>
+          </a:xfrm>
+          <a:prstGeom prst="rect">
+            <a:avLst/>
+          </a:prstGeom>
+          <a:noFill/>
+          <a:ln w="0">
+            <a:noFill/>
+          </a:ln>
+        </p:spPr>
+        <p:txBody>
+          <a:bodyPr lIns="91440" rIns="91440" tIns="91440" bIns="91440" anchor="ctr">
+            <a:normAutofit/>
+          </a:bodyPr>
+          <a:lstStyle>
+            <a:lvl1pPr indent="0" algn="r">
+              <a:lnSpc>
+                <a:spcPct val="100000"/>
+              </a:lnSpc>
+              <a:buNone/>
+              <a:tabLst>
+                <a:tab algn="l" pos="0"/>
+              </a:tabLst>
+              <a:defRPr b="0" lang="en" sz="1000" strike="noStrike" u="none">
+                <a:solidFill>
+                  <a:schemeClr val="dk2"/>
+                </a:solidFill>
+                <a:effectLst/>
+                <a:uFillTx/>
+                <a:latin typeface="Arial"/>
+                <a:ea typeface="Arial"/>
+              </a:defRPr>
+            </a:lvl1pPr>
+          </a:lstStyle>
+          <a:p>
+            <a:pPr indent="0" algn="r">
+              <a:lnSpc>
+                <a:spcPct val="100000"/>
+              </a:lnSpc>
+              <a:buNone/>
+              <a:tabLst>
+                <a:tab algn="l" pos="0"/>
+              </a:tabLst>
+            </a:pPr>
+            <a:fld id="{0B14563C-5F2E-482C-B0D7-FF11CC09406A}" type="slidenum">
+              <a:rPr b="0" lang="en" sz="1000" strike="noStrike" u="none">
+                <a:solidFill>
+                  <a:schemeClr val="dk2"/>
+                </a:solidFill>
+                <a:effectLst/>
+                <a:uFillTx/>
+                <a:latin typeface="Arial"/>
+                <a:ea typeface="Arial"/>
+              </a:rPr>
+              <a:t>&lt;número&gt;</a:t>
+            </a:fld>
+            <a:endParaRPr b="0" lang="es-MX" sz="1000" strike="noStrike" u="none">
+              <a:solidFill>
+                <a:srgbClr val="000000"/>
+              </a:solidFill>
+              <a:effectLst/>
+              <a:uFillTx/>
+              <a:latin typeface="Times New Roman"/>
+            </a:endParaRPr>
+          </a:p>
+        </p:txBody>
+      </p:sp>
+    </p:spTree>
+  </p:cSld>
+</p:sldLayout>
+</file>
+
+<file path=ppt/slideLayouts/slideLayout4.xml><?xml version="1.0" encoding="utf-8"?>
+<p:sldLayout xmlns:a="http://schemas.openxmlformats.org/drawingml/2006/main" xmlns:p="http://schemas.openxmlformats.org/presentationml/2006/main" xmlns:r="http://schemas.openxmlformats.org/officeDocument/2006/relationships" xmlns:p14="http://schemas.microsoft.com/office/powerpoint/2010/main" xmlns:p15="http://schemas.microsoft.com/office/powerpoint/2012/main" xmlns:mc="http://schemas.openxmlformats.org/markup-compatibility/2006" type="blank" preserve="1">
+  <p:cSld name="CAPTION_ONLY">
     <p:bg>
       <p:bgPr>
         <a:solidFill>
@@ -776,13 +726,13 @@
             <a:spLocks noGrp="1"/>
           </p:cNvSpPr>
           <p:nvPr>
-            <p:ph type="sldNum" idx="2"/>
+            <p:ph type="sldNum" idx="4"/>
           </p:nvPr>
         </p:nvSpPr>
         <p:spPr>
           <a:xfrm>
             <a:off x="8472600" y="4663080"/>
-            <a:ext cx="548280" cy="393120"/>
+            <a:ext cx="547920" cy="392760"/>
           </a:xfrm>
           <a:prstGeom prst="rect">
             <a:avLst/>
@@ -794,51 +744,13 @@
         </p:spPr>
         <p:txBody>
           <a:bodyPr lIns="91440" rIns="91440" tIns="91440" bIns="91440" anchor="ctr">
-            <a:normAutofit/>
+            <a:normAutofit fontScale="55000" lnSpcReduction="19999"/>
           </a:bodyPr>
-          <a:lstStyle>
-            <a:lvl1pPr indent="0" algn="r">
-              <a:lnSpc>
-                <a:spcPct val="100000"/>
-              </a:lnSpc>
+          <a:p>
+            <a:pPr indent="0">
               <a:buNone/>
-              <a:tabLst>
-                <a:tab algn="l" pos="0"/>
-              </a:tabLst>
-              <a:defRPr b="0" lang="en" sz="1000" strike="noStrike" u="none">
-                <a:solidFill>
-                  <a:schemeClr val="dk2"/>
-                </a:solidFill>
-                <a:effectLst/>
-                <a:uFillTx/>
-                <a:latin typeface="Arial"/>
-                <a:ea typeface="Arial"/>
-              </a:defRPr>
-            </a:lvl1pPr>
-          </a:lstStyle>
-          <a:p>
-            <a:pPr indent="0" algn="r">
-              <a:lnSpc>
-                <a:spcPct val="100000"/>
-              </a:lnSpc>
-              <a:buNone/>
-              <a:tabLst>
-                <a:tab algn="l" pos="0"/>
-              </a:tabLst>
-            </a:pPr>
-            <a:fld id="{94C37AE8-178A-46E6-800E-DFB98898F091}" type="slidenum">
-              <a:rPr b="0" lang="en" sz="1000" strike="noStrike" u="none">
-                <a:solidFill>
-                  <a:schemeClr val="dk2"/>
-                </a:solidFill>
-                <a:effectLst/>
-                <a:uFillTx/>
-                <a:latin typeface="Arial"/>
-                <a:ea typeface="Arial"/>
-              </a:rPr>
-              <a:t>&lt;número&gt;</a:t>
-            </a:fld>
-            <a:endParaRPr b="0" lang="es-MX" sz="1000" strike="noStrike" u="none">
+            </a:pPr>
+            <a:endParaRPr b="0" lang="es-MX" sz="1800" strike="noStrike" u="none">
               <a:solidFill>
                 <a:srgbClr val="000000"/>
               </a:solidFill>
@@ -854,9 +766,9 @@
 </p:sldLayout>
 </file>
 
-<file path=ppt/slideLayouts/slideLayout3.xml><?xml version="1.0" encoding="utf-8"?>
-<p:sldLayout xmlns:a="http://schemas.openxmlformats.org/drawingml/2006/main" xmlns:p="http://schemas.openxmlformats.org/presentationml/2006/main" xmlns:r="http://schemas.openxmlformats.org/officeDocument/2006/relationships" xmlns:p14="http://schemas.microsoft.com/office/powerpoint/2010/main" xmlns:p15="http://schemas.microsoft.com/office/powerpoint/2012/main" xmlns:mc="http://schemas.openxmlformats.org/markup-compatibility/2006" type="blank" preserve="1">
-  <p:cSld name="BLANK">
+<file path=ppt/slideLayouts/slideLayout5.xml><?xml version="1.0" encoding="utf-8"?>
+<p:sldLayout xmlns:a="http://schemas.openxmlformats.org/drawingml/2006/main" xmlns:p="http://schemas.openxmlformats.org/presentationml/2006/main" xmlns:r="http://schemas.openxmlformats.org/officeDocument/2006/relationships" xmlns:p14="http://schemas.microsoft.com/office/powerpoint/2010/main" xmlns:p15="http://schemas.microsoft.com/office/powerpoint/2012/main" xmlns:mc="http://schemas.openxmlformats.org/markup-compatibility/2006" type="title" preserve="1">
+  <p:cSld name="TITLE">
     <p:bg>
       <p:bgPr>
         <a:solidFill>
@@ -885,13 +797,13 @@
             <a:spLocks noGrp="1"/>
           </p:cNvSpPr>
           <p:nvPr>
-            <p:ph type="sldNum" idx="3"/>
+            <p:ph type="sldNum" idx="5"/>
           </p:nvPr>
         </p:nvSpPr>
         <p:spPr>
           <a:xfrm>
             <a:off x="8472600" y="4663080"/>
-            <a:ext cx="548280" cy="393120"/>
+            <a:ext cx="547920" cy="392760"/>
           </a:xfrm>
           <a:prstGeom prst="rect">
             <a:avLst/>
@@ -935,7 +847,7 @@
                 <a:tab algn="l" pos="0"/>
               </a:tabLst>
             </a:pPr>
-            <a:fld id="{8E1EE2C9-E0D8-485A-B676-13728B4BC2FD}" type="slidenum">
+            <a:fld id="{7C3ABF43-C76F-4438-A3D0-98A36BBC421E}" type="slidenum">
               <a:rPr b="0" lang="en" sz="1000" strike="noStrike" u="none">
                 <a:solidFill>
                   <a:schemeClr val="dk2"/>
@@ -971,7 +883,7 @@
         <p:spPr>
           <a:xfrm>
             <a:off x="457200" y="205200"/>
-            <a:ext cx="8229240" cy="858600"/>
+            <a:ext cx="8228880" cy="858240"/>
           </a:xfrm>
           <a:prstGeom prst="rect">
             <a:avLst/>
@@ -987,7 +899,13 @@
           </a:bodyPr>
           <a:p>
             <a:pPr indent="0">
+              <a:lnSpc>
+                <a:spcPct val="100000"/>
+              </a:lnSpc>
               <a:buNone/>
+              <a:tabLst>
+                <a:tab algn="l" pos="0"/>
+              </a:tabLst>
             </a:pPr>
             <a:r>
               <a:rPr b="0" lang="es-MX" sz="1400" strike="noStrike" u="none">
@@ -1024,7 +942,7 @@
         <p:spPr>
           <a:xfrm>
             <a:off x="457200" y="1203480"/>
-            <a:ext cx="8229240" cy="2982960"/>
+            <a:ext cx="8228880" cy="2982600"/>
           </a:xfrm>
           <a:prstGeom prst="rect">
             <a:avLst/>
@@ -1040,6 +958,9 @@
           </a:bodyPr>
           <a:p>
             <a:pPr marL="432000" indent="-324000">
+              <a:lnSpc>
+                <a:spcPct val="100000"/>
+              </a:lnSpc>
               <a:spcBef>
                 <a:spcPts val="1417"/>
               </a:spcBef>
@@ -1072,6 +993,9 @@
           </a:p>
           <a:p>
             <a:pPr lvl="1" marL="864000" indent="-324000">
+              <a:lnSpc>
+                <a:spcPct val="100000"/>
+              </a:lnSpc>
               <a:spcBef>
                 <a:spcPts val="1134"/>
               </a:spcBef>
@@ -1104,6 +1028,9 @@
           </a:p>
           <a:p>
             <a:pPr lvl="2" marL="1296000" indent="-288000">
+              <a:lnSpc>
+                <a:spcPct val="100000"/>
+              </a:lnSpc>
               <a:spcBef>
                 <a:spcPts val="850"/>
               </a:spcBef>
@@ -1136,6 +1063,9 @@
           </a:p>
           <a:p>
             <a:pPr lvl="3" marL="1728000" indent="-216000">
+              <a:lnSpc>
+                <a:spcPct val="100000"/>
+              </a:lnSpc>
               <a:spcBef>
                 <a:spcPts val="567"/>
               </a:spcBef>
@@ -1168,6 +1098,9 @@
           </a:p>
           <a:p>
             <a:pPr lvl="4" marL="2160000" indent="-216000">
+              <a:lnSpc>
+                <a:spcPct val="100000"/>
+              </a:lnSpc>
               <a:spcBef>
                 <a:spcPts val="283"/>
               </a:spcBef>
@@ -1200,6 +1133,9 @@
           </a:p>
           <a:p>
             <a:pPr lvl="5" marL="2592000" indent="-216000">
+              <a:lnSpc>
+                <a:spcPct val="100000"/>
+              </a:lnSpc>
               <a:spcBef>
                 <a:spcPts val="283"/>
               </a:spcBef>
@@ -1232,6 +1168,9 @@
           </a:p>
           <a:p>
             <a:pPr lvl="6" marL="3024000" indent="-216000">
+              <a:lnSpc>
+                <a:spcPct val="100000"/>
+              </a:lnSpc>
               <a:spcBef>
                 <a:spcPts val="283"/>
               </a:spcBef>
@@ -1269,7 +1208,558 @@
 </p:sldLayout>
 </file>
 
-<file path=ppt/slideLayouts/slideLayout4.xml><?xml version="1.0" encoding="utf-8"?>
+<file path=ppt/slideLayouts/slideLayout6.xml><?xml version="1.0" encoding="utf-8"?>
+<p:sldLayout xmlns:a="http://schemas.openxmlformats.org/drawingml/2006/main" xmlns:p="http://schemas.openxmlformats.org/presentationml/2006/main" xmlns:r="http://schemas.openxmlformats.org/officeDocument/2006/relationships" xmlns:p14="http://schemas.microsoft.com/office/powerpoint/2010/main" xmlns:p15="http://schemas.microsoft.com/office/powerpoint/2012/main" xmlns:mc="http://schemas.openxmlformats.org/markup-compatibility/2006" type="blank" preserve="1">
+  <p:cSld name="BIG_NUMBER">
+    <p:bg>
+      <p:bgPr>
+        <a:solidFill>
+          <a:schemeClr val="lt1"/>
+        </a:solidFill>
+      </p:bgPr>
+    </p:bg>
+    <p:spTree>
+      <p:nvGrpSpPr>
+        <p:cNvPr id="1" name=""/>
+        <p:cNvGrpSpPr/>
+        <p:nvPr/>
+      </p:nvGrpSpPr>
+      <p:grpSpPr>
+        <a:xfrm>
+          <a:off x="0" y="0"/>
+          <a:ext cx="0" cy="0"/>
+          <a:chOff x="0" y="0"/>
+          <a:chExt cx="0" cy="0"/>
+        </a:xfrm>
+      </p:grpSpPr>
+      <p:sp>
+        <p:nvSpPr>
+          <p:cNvPr id="9" name="PlaceHolder 1"/>
+          <p:cNvSpPr>
+            <a:spLocks noGrp="1"/>
+          </p:cNvSpPr>
+          <p:nvPr>
+            <p:ph type="sldNum" idx="6"/>
+          </p:nvPr>
+        </p:nvSpPr>
+        <p:spPr>
+          <a:xfrm>
+            <a:off x="8472600" y="4663080"/>
+            <a:ext cx="547920" cy="392760"/>
+          </a:xfrm>
+          <a:prstGeom prst="rect">
+            <a:avLst/>
+          </a:prstGeom>
+          <a:noFill/>
+          <a:ln w="0">
+            <a:noFill/>
+          </a:ln>
+        </p:spPr>
+        <p:txBody>
+          <a:bodyPr lIns="91440" rIns="91440" tIns="91440" bIns="91440" anchor="ctr">
+            <a:normAutofit/>
+          </a:bodyPr>
+          <a:lstStyle>
+            <a:lvl1pPr indent="0" algn="r">
+              <a:lnSpc>
+                <a:spcPct val="100000"/>
+              </a:lnSpc>
+              <a:buNone/>
+              <a:tabLst>
+                <a:tab algn="l" pos="0"/>
+              </a:tabLst>
+              <a:defRPr b="0" lang="en" sz="1000" strike="noStrike" u="none">
+                <a:solidFill>
+                  <a:schemeClr val="dk2"/>
+                </a:solidFill>
+                <a:effectLst/>
+                <a:uFillTx/>
+                <a:latin typeface="Arial"/>
+                <a:ea typeface="Arial"/>
+              </a:defRPr>
+            </a:lvl1pPr>
+          </a:lstStyle>
+          <a:p>
+            <a:pPr indent="0" algn="r">
+              <a:lnSpc>
+                <a:spcPct val="100000"/>
+              </a:lnSpc>
+              <a:buNone/>
+              <a:tabLst>
+                <a:tab algn="l" pos="0"/>
+              </a:tabLst>
+            </a:pPr>
+            <a:fld id="{BA1F1EB9-ACE2-448F-B9CD-821790111BAB}" type="slidenum">
+              <a:rPr b="0" lang="en" sz="1000" strike="noStrike" u="none">
+                <a:solidFill>
+                  <a:schemeClr val="dk2"/>
+                </a:solidFill>
+                <a:effectLst/>
+                <a:uFillTx/>
+                <a:latin typeface="Arial"/>
+                <a:ea typeface="Arial"/>
+              </a:rPr>
+              <a:t>&lt;número&gt;</a:t>
+            </a:fld>
+            <a:endParaRPr b="0" lang="es-MX" sz="1000" strike="noStrike" u="none">
+              <a:solidFill>
+                <a:srgbClr val="000000"/>
+              </a:solidFill>
+              <a:effectLst/>
+              <a:uFillTx/>
+              <a:latin typeface="Times New Roman"/>
+            </a:endParaRPr>
+          </a:p>
+        </p:txBody>
+      </p:sp>
+    </p:spTree>
+  </p:cSld>
+</p:sldLayout>
+</file>
+
+<file path=ppt/slideLayouts/slideLayout7.xml><?xml version="1.0" encoding="utf-8"?>
+<p:sldLayout xmlns:a="http://schemas.openxmlformats.org/drawingml/2006/main" xmlns:p="http://schemas.openxmlformats.org/presentationml/2006/main" xmlns:r="http://schemas.openxmlformats.org/officeDocument/2006/relationships" xmlns:p14="http://schemas.microsoft.com/office/powerpoint/2010/main" xmlns:p15="http://schemas.microsoft.com/office/powerpoint/2012/main" xmlns:mc="http://schemas.openxmlformats.org/markup-compatibility/2006" type="blank" preserve="1">
+  <p:cSld name="BLANK">
+    <p:bg>
+      <p:bgPr>
+        <a:solidFill>
+          <a:schemeClr val="lt1"/>
+        </a:solidFill>
+      </p:bgPr>
+    </p:bg>
+    <p:spTree>
+      <p:nvGrpSpPr>
+        <p:cNvPr id="1" name=""/>
+        <p:cNvGrpSpPr/>
+        <p:nvPr/>
+      </p:nvGrpSpPr>
+      <p:grpSpPr>
+        <a:xfrm>
+          <a:off x="0" y="0"/>
+          <a:ext cx="0" cy="0"/>
+          <a:chOff x="0" y="0"/>
+          <a:chExt cx="0" cy="0"/>
+        </a:xfrm>
+      </p:grpSpPr>
+      <p:sp>
+        <p:nvSpPr>
+          <p:cNvPr id="10" name="PlaceHolder 1"/>
+          <p:cNvSpPr>
+            <a:spLocks noGrp="1"/>
+          </p:cNvSpPr>
+          <p:nvPr>
+            <p:ph type="sldNum" idx="7"/>
+          </p:nvPr>
+        </p:nvSpPr>
+        <p:spPr>
+          <a:xfrm>
+            <a:off x="8472600" y="4663080"/>
+            <a:ext cx="547920" cy="392760"/>
+          </a:xfrm>
+          <a:prstGeom prst="rect">
+            <a:avLst/>
+          </a:prstGeom>
+          <a:noFill/>
+          <a:ln w="0">
+            <a:noFill/>
+          </a:ln>
+        </p:spPr>
+        <p:txBody>
+          <a:bodyPr lIns="91440" rIns="91440" tIns="91440" bIns="91440" anchor="ctr">
+            <a:normAutofit/>
+          </a:bodyPr>
+          <a:lstStyle>
+            <a:lvl1pPr indent="0" algn="r">
+              <a:lnSpc>
+                <a:spcPct val="100000"/>
+              </a:lnSpc>
+              <a:buNone/>
+              <a:tabLst>
+                <a:tab algn="l" pos="0"/>
+              </a:tabLst>
+              <a:defRPr b="0" lang="en" sz="1000" strike="noStrike" u="none">
+                <a:solidFill>
+                  <a:schemeClr val="dk2"/>
+                </a:solidFill>
+                <a:effectLst/>
+                <a:uFillTx/>
+                <a:latin typeface="Arial"/>
+                <a:ea typeface="Arial"/>
+              </a:defRPr>
+            </a:lvl1pPr>
+          </a:lstStyle>
+          <a:p>
+            <a:pPr indent="0" algn="r">
+              <a:lnSpc>
+                <a:spcPct val="100000"/>
+              </a:lnSpc>
+              <a:buNone/>
+              <a:tabLst>
+                <a:tab algn="l" pos="0"/>
+              </a:tabLst>
+            </a:pPr>
+            <a:fld id="{D814C344-2FF3-4484-8E2A-E9446A22F3BB}" type="slidenum">
+              <a:rPr b="0" lang="en" sz="1000" strike="noStrike" u="none">
+                <a:solidFill>
+                  <a:schemeClr val="dk2"/>
+                </a:solidFill>
+                <a:effectLst/>
+                <a:uFillTx/>
+                <a:latin typeface="Arial"/>
+                <a:ea typeface="Arial"/>
+              </a:rPr>
+              <a:t>&lt;número&gt;</a:t>
+            </a:fld>
+            <a:endParaRPr b="0" lang="es-MX" sz="1000" strike="noStrike" u="none">
+              <a:solidFill>
+                <a:srgbClr val="000000"/>
+              </a:solidFill>
+              <a:effectLst/>
+              <a:uFillTx/>
+              <a:latin typeface="Times New Roman"/>
+            </a:endParaRPr>
+          </a:p>
+        </p:txBody>
+      </p:sp>
+      <p:sp>
+        <p:nvSpPr>
+          <p:cNvPr id="11" name="PlaceHolder 2"/>
+          <p:cNvSpPr>
+            <a:spLocks noGrp="1"/>
+          </p:cNvSpPr>
+          <p:nvPr>
+            <p:ph type="title"/>
+          </p:nvPr>
+        </p:nvSpPr>
+        <p:spPr>
+          <a:xfrm>
+            <a:off x="457200" y="205200"/>
+            <a:ext cx="8228880" cy="858240"/>
+          </a:xfrm>
+          <a:prstGeom prst="rect">
+            <a:avLst/>
+          </a:prstGeom>
+          <a:noFill/>
+          <a:ln w="0">
+            <a:noFill/>
+          </a:ln>
+        </p:spPr>
+        <p:txBody>
+          <a:bodyPr lIns="0" rIns="0" tIns="0" bIns="0" anchor="ctr">
+            <a:noAutofit/>
+          </a:bodyPr>
+          <a:p>
+            <a:pPr indent="0">
+              <a:lnSpc>
+                <a:spcPct val="100000"/>
+              </a:lnSpc>
+              <a:buNone/>
+              <a:tabLst>
+                <a:tab algn="l" pos="0"/>
+              </a:tabLst>
+            </a:pPr>
+            <a:r>
+              <a:rPr b="0" lang="es-MX" sz="1400" strike="noStrike" u="none">
+                <a:solidFill>
+                  <a:srgbClr val="000000"/>
+                </a:solidFill>
+                <a:effectLst/>
+                <a:uFillTx/>
+                <a:latin typeface="Arial"/>
+              </a:rPr>
+              <a:t>Pulse para editar el formato del texto de título</a:t>
+            </a:r>
+            <a:endParaRPr b="0" lang="es-MX" sz="1400" strike="noStrike" u="none">
+              <a:solidFill>
+                <a:srgbClr val="000000"/>
+              </a:solidFill>
+              <a:effectLst/>
+              <a:uFillTx/>
+              <a:latin typeface="Arial"/>
+            </a:endParaRPr>
+          </a:p>
+        </p:txBody>
+      </p:sp>
+      <p:sp>
+        <p:nvSpPr>
+          <p:cNvPr id="12" name="PlaceHolder 3"/>
+          <p:cNvSpPr>
+            <a:spLocks noGrp="1"/>
+          </p:cNvSpPr>
+          <p:nvPr>
+            <p:ph type="body"/>
+          </p:nvPr>
+        </p:nvSpPr>
+        <p:spPr>
+          <a:xfrm>
+            <a:off x="457200" y="1203480"/>
+            <a:ext cx="8228880" cy="2982600"/>
+          </a:xfrm>
+          <a:prstGeom prst="rect">
+            <a:avLst/>
+          </a:prstGeom>
+          <a:noFill/>
+          <a:ln w="0">
+            <a:noFill/>
+          </a:ln>
+        </p:spPr>
+        <p:txBody>
+          <a:bodyPr lIns="0" rIns="0" tIns="0" bIns="0" anchor="t">
+            <a:normAutofit/>
+          </a:bodyPr>
+          <a:p>
+            <a:pPr marL="432000" indent="-324000">
+              <a:lnSpc>
+                <a:spcPct val="100000"/>
+              </a:lnSpc>
+              <a:spcBef>
+                <a:spcPts val="1417"/>
+              </a:spcBef>
+              <a:buClr>
+                <a:srgbClr val="000000"/>
+              </a:buClr>
+              <a:buSzPct val="45000"/>
+              <a:buFont typeface="Wingdings" charset="2"/>
+              <a:buChar char=""/>
+            </a:pPr>
+            <a:r>
+              <a:rPr b="0" lang="es-MX" sz="1400" strike="noStrike" u="none">
+                <a:solidFill>
+                  <a:srgbClr val="000000"/>
+                </a:solidFill>
+                <a:effectLst/>
+                <a:uFillTx/>
+                <a:latin typeface="Arial"/>
+              </a:rPr>
+              <a:t>Pulse para editar el formato de texto del esquema</a:t>
+            </a:r>
+            <a:endParaRPr b="0" lang="es-MX" sz="1400" strike="noStrike" u="none">
+              <a:solidFill>
+                <a:srgbClr val="000000"/>
+              </a:solidFill>
+              <a:effectLst/>
+              <a:uFillTx/>
+              <a:latin typeface="Arial"/>
+            </a:endParaRPr>
+          </a:p>
+          <a:p>
+            <a:pPr lvl="1" marL="864000" indent="-324000">
+              <a:lnSpc>
+                <a:spcPct val="100000"/>
+              </a:lnSpc>
+              <a:spcBef>
+                <a:spcPts val="1134"/>
+              </a:spcBef>
+              <a:buClr>
+                <a:srgbClr val="000000"/>
+              </a:buClr>
+              <a:buSzPct val="75000"/>
+              <a:buFont typeface="Symbol" charset="2"/>
+              <a:buChar char=""/>
+            </a:pPr>
+            <a:r>
+              <a:rPr b="0" lang="es-MX" sz="1400" strike="noStrike" u="none">
+                <a:solidFill>
+                  <a:srgbClr val="000000"/>
+                </a:solidFill>
+                <a:effectLst/>
+                <a:uFillTx/>
+                <a:latin typeface="Arial"/>
+              </a:rPr>
+              <a:t>Segundo nivel del esquema</a:t>
+            </a:r>
+            <a:endParaRPr b="0" lang="es-MX" sz="1400" strike="noStrike" u="none">
+              <a:solidFill>
+                <a:srgbClr val="000000"/>
+              </a:solidFill>
+              <a:effectLst/>
+              <a:uFillTx/>
+              <a:latin typeface="Arial"/>
+            </a:endParaRPr>
+          </a:p>
+          <a:p>
+            <a:pPr lvl="2" marL="1296000" indent="-288000">
+              <a:lnSpc>
+                <a:spcPct val="100000"/>
+              </a:lnSpc>
+              <a:spcBef>
+                <a:spcPts val="850"/>
+              </a:spcBef>
+              <a:buClr>
+                <a:srgbClr val="000000"/>
+              </a:buClr>
+              <a:buSzPct val="45000"/>
+              <a:buFont typeface="Wingdings" charset="2"/>
+              <a:buChar char=""/>
+            </a:pPr>
+            <a:r>
+              <a:rPr b="0" lang="es-MX" sz="1400" strike="noStrike" u="none">
+                <a:solidFill>
+                  <a:srgbClr val="000000"/>
+                </a:solidFill>
+                <a:effectLst/>
+                <a:uFillTx/>
+                <a:latin typeface="Arial"/>
+              </a:rPr>
+              <a:t>Tercer nivel del esquema</a:t>
+            </a:r>
+            <a:endParaRPr b="0" lang="es-MX" sz="1400" strike="noStrike" u="none">
+              <a:solidFill>
+                <a:srgbClr val="000000"/>
+              </a:solidFill>
+              <a:effectLst/>
+              <a:uFillTx/>
+              <a:latin typeface="Arial"/>
+            </a:endParaRPr>
+          </a:p>
+          <a:p>
+            <a:pPr lvl="3" marL="1728000" indent="-216000">
+              <a:lnSpc>
+                <a:spcPct val="100000"/>
+              </a:lnSpc>
+              <a:spcBef>
+                <a:spcPts val="567"/>
+              </a:spcBef>
+              <a:buClr>
+                <a:srgbClr val="000000"/>
+              </a:buClr>
+              <a:buSzPct val="75000"/>
+              <a:buFont typeface="Symbol" charset="2"/>
+              <a:buChar char=""/>
+            </a:pPr>
+            <a:r>
+              <a:rPr b="0" lang="es-MX" sz="1400" strike="noStrike" u="none">
+                <a:solidFill>
+                  <a:srgbClr val="000000"/>
+                </a:solidFill>
+                <a:effectLst/>
+                <a:uFillTx/>
+                <a:latin typeface="Arial"/>
+              </a:rPr>
+              <a:t>Cuarto nivel del esquema</a:t>
+            </a:r>
+            <a:endParaRPr b="0" lang="es-MX" sz="1400" strike="noStrike" u="none">
+              <a:solidFill>
+                <a:srgbClr val="000000"/>
+              </a:solidFill>
+              <a:effectLst/>
+              <a:uFillTx/>
+              <a:latin typeface="Arial"/>
+            </a:endParaRPr>
+          </a:p>
+          <a:p>
+            <a:pPr lvl="4" marL="2160000" indent="-216000">
+              <a:lnSpc>
+                <a:spcPct val="100000"/>
+              </a:lnSpc>
+              <a:spcBef>
+                <a:spcPts val="283"/>
+              </a:spcBef>
+              <a:buClr>
+                <a:srgbClr val="000000"/>
+              </a:buClr>
+              <a:buSzPct val="45000"/>
+              <a:buFont typeface="Wingdings" charset="2"/>
+              <a:buChar char=""/>
+            </a:pPr>
+            <a:r>
+              <a:rPr b="0" lang="es-MX" sz="2000" strike="noStrike" u="none">
+                <a:solidFill>
+                  <a:srgbClr val="000000"/>
+                </a:solidFill>
+                <a:effectLst/>
+                <a:uFillTx/>
+                <a:latin typeface="Arial"/>
+              </a:rPr>
+              <a:t>Quinto nivel del esquema</a:t>
+            </a:r>
+            <a:endParaRPr b="0" lang="es-MX" sz="2000" strike="noStrike" u="none">
+              <a:solidFill>
+                <a:srgbClr val="000000"/>
+              </a:solidFill>
+              <a:effectLst/>
+              <a:uFillTx/>
+              <a:latin typeface="Arial"/>
+            </a:endParaRPr>
+          </a:p>
+          <a:p>
+            <a:pPr lvl="5" marL="2592000" indent="-216000">
+              <a:lnSpc>
+                <a:spcPct val="100000"/>
+              </a:lnSpc>
+              <a:spcBef>
+                <a:spcPts val="283"/>
+              </a:spcBef>
+              <a:buClr>
+                <a:srgbClr val="000000"/>
+              </a:buClr>
+              <a:buSzPct val="45000"/>
+              <a:buFont typeface="Wingdings" charset="2"/>
+              <a:buChar char=""/>
+            </a:pPr>
+            <a:r>
+              <a:rPr b="0" lang="es-MX" sz="2000" strike="noStrike" u="none">
+                <a:solidFill>
+                  <a:srgbClr val="000000"/>
+                </a:solidFill>
+                <a:effectLst/>
+                <a:uFillTx/>
+                <a:latin typeface="Arial"/>
+              </a:rPr>
+              <a:t>Sexto nivel del esquema</a:t>
+            </a:r>
+            <a:endParaRPr b="0" lang="es-MX" sz="2000" strike="noStrike" u="none">
+              <a:solidFill>
+                <a:srgbClr val="000000"/>
+              </a:solidFill>
+              <a:effectLst/>
+              <a:uFillTx/>
+              <a:latin typeface="Arial"/>
+            </a:endParaRPr>
+          </a:p>
+          <a:p>
+            <a:pPr lvl="6" marL="3024000" indent="-216000">
+              <a:lnSpc>
+                <a:spcPct val="100000"/>
+              </a:lnSpc>
+              <a:spcBef>
+                <a:spcPts val="283"/>
+              </a:spcBef>
+              <a:buClr>
+                <a:srgbClr val="000000"/>
+              </a:buClr>
+              <a:buSzPct val="45000"/>
+              <a:buFont typeface="Wingdings" charset="2"/>
+              <a:buChar char=""/>
+            </a:pPr>
+            <a:r>
+              <a:rPr b="0" lang="es-MX" sz="2000" strike="noStrike" u="none">
+                <a:solidFill>
+                  <a:srgbClr val="000000"/>
+                </a:solidFill>
+                <a:effectLst/>
+                <a:uFillTx/>
+                <a:latin typeface="Arial"/>
+              </a:rPr>
+              <a:t>Séptimo nivel del esquema</a:t>
+            </a:r>
+            <a:endParaRPr b="0" lang="es-MX" sz="2000" strike="noStrike" u="none">
+              <a:solidFill>
+                <a:srgbClr val="000000"/>
+              </a:solidFill>
+              <a:effectLst/>
+              <a:uFillTx/>
+              <a:latin typeface="Arial"/>
+            </a:endParaRPr>
+          </a:p>
+        </p:txBody>
+      </p:sp>
+    </p:spTree>
+  </p:cSld>
+</p:sldLayout>
+</file>
+
+<file path=ppt/slideLayouts/slideLayout8.xml><?xml version="1.0" encoding="utf-8"?>
 <p:sldLayout xmlns:a="http://schemas.openxmlformats.org/drawingml/2006/main" xmlns:p="http://schemas.openxmlformats.org/presentationml/2006/main" xmlns:r="http://schemas.openxmlformats.org/officeDocument/2006/relationships" xmlns:p14="http://schemas.microsoft.com/office/powerpoint/2010/main" xmlns:p15="http://schemas.microsoft.com/office/powerpoint/2012/main" xmlns:mc="http://schemas.openxmlformats.org/markup-compatibility/2006" type="blank" preserve="1">
   <p:cSld name="DEFAULT">
     <p:bg>
@@ -1298,7 +1788,7 @@
 </p:sldLayout>
 </file>
 
-<file path=ppt/slideLayouts/slideLayout5.xml><?xml version="1.0" encoding="utf-8"?>
+<file path=ppt/slideLayouts/slideLayout9.xml><?xml version="1.0" encoding="utf-8"?>
 <p:sldLayout xmlns:a="http://schemas.openxmlformats.org/drawingml/2006/main" xmlns:p="http://schemas.openxmlformats.org/presentationml/2006/main" xmlns:r="http://schemas.openxmlformats.org/officeDocument/2006/relationships" xmlns:p14="http://schemas.microsoft.com/office/powerpoint/2010/main" xmlns:p15="http://schemas.microsoft.com/office/powerpoint/2012/main" xmlns:mc="http://schemas.openxmlformats.org/markup-compatibility/2006" type="blank" preserve="1">
   <p:cSld name="SECTION_HEADER">
     <p:bg>
@@ -1322,442 +1812,6 @@
           <a:chExt cx="0" cy="0"/>
         </a:xfrm>
       </p:grpSpPr>
-    </p:spTree>
-  </p:cSld>
-</p:sldLayout>
-</file>
-
-<file path=ppt/slideLayouts/slideLayout6.xml><?xml version="1.0" encoding="utf-8"?>
-<p:sldLayout xmlns:a="http://schemas.openxmlformats.org/drawingml/2006/main" xmlns:p="http://schemas.openxmlformats.org/presentationml/2006/main" xmlns:r="http://schemas.openxmlformats.org/officeDocument/2006/relationships" xmlns:p14="http://schemas.microsoft.com/office/powerpoint/2010/main" xmlns:p15="http://schemas.microsoft.com/office/powerpoint/2012/main" xmlns:mc="http://schemas.openxmlformats.org/markup-compatibility/2006" type="tx" preserve="1">
-  <p:cSld name="TITLE_AND_BODY">
-    <p:bg>
-      <p:bgPr>
-        <a:solidFill>
-          <a:schemeClr val="lt1"/>
-        </a:solidFill>
-      </p:bgPr>
-    </p:bg>
-    <p:spTree>
-      <p:nvGrpSpPr>
-        <p:cNvPr id="1" name=""/>
-        <p:cNvGrpSpPr/>
-        <p:nvPr/>
-      </p:nvGrpSpPr>
-      <p:grpSpPr>
-        <a:xfrm>
-          <a:off x="0" y="0"/>
-          <a:ext cx="0" cy="0"/>
-          <a:chOff x="0" y="0"/>
-          <a:chExt cx="0" cy="0"/>
-        </a:xfrm>
-      </p:grpSpPr>
-      <p:sp>
-        <p:nvSpPr>
-          <p:cNvPr id="9" name="PlaceHolder 1"/>
-          <p:cNvSpPr>
-            <a:spLocks noGrp="1"/>
-          </p:cNvSpPr>
-          <p:nvPr>
-            <p:ph type="sldNum" idx="4"/>
-          </p:nvPr>
-        </p:nvSpPr>
-        <p:spPr>
-          <a:xfrm>
-            <a:off x="8472600" y="4663080"/>
-            <a:ext cx="548280" cy="393120"/>
-          </a:xfrm>
-          <a:prstGeom prst="rect">
-            <a:avLst/>
-          </a:prstGeom>
-          <a:noFill/>
-          <a:ln w="0">
-            <a:noFill/>
-          </a:ln>
-        </p:spPr>
-        <p:txBody>
-          <a:bodyPr lIns="91440" rIns="91440" tIns="91440" bIns="91440" anchor="ctr">
-            <a:normAutofit/>
-          </a:bodyPr>
-          <a:lstStyle>
-            <a:lvl1pPr indent="0" algn="r">
-              <a:lnSpc>
-                <a:spcPct val="100000"/>
-              </a:lnSpc>
-              <a:buNone/>
-              <a:tabLst>
-                <a:tab algn="l" pos="0"/>
-              </a:tabLst>
-              <a:defRPr b="0" lang="en" sz="1000" strike="noStrike" u="none">
-                <a:solidFill>
-                  <a:schemeClr val="dk2"/>
-                </a:solidFill>
-                <a:effectLst/>
-                <a:uFillTx/>
-                <a:latin typeface="Arial"/>
-                <a:ea typeface="Arial"/>
-              </a:defRPr>
-            </a:lvl1pPr>
-          </a:lstStyle>
-          <a:p>
-            <a:pPr indent="0" algn="r">
-              <a:lnSpc>
-                <a:spcPct val="100000"/>
-              </a:lnSpc>
-              <a:buNone/>
-              <a:tabLst>
-                <a:tab algn="l" pos="0"/>
-              </a:tabLst>
-            </a:pPr>
-            <a:fld id="{6F480701-E86C-40C3-A207-FAA8287DAE0D}" type="slidenum">
-              <a:rPr b="0" lang="en" sz="1000" strike="noStrike" u="none">
-                <a:solidFill>
-                  <a:schemeClr val="dk2"/>
-                </a:solidFill>
-                <a:effectLst/>
-                <a:uFillTx/>
-                <a:latin typeface="Arial"/>
-                <a:ea typeface="Arial"/>
-              </a:rPr>
-              <a:t>&lt;número&gt;</a:t>
-            </a:fld>
-            <a:endParaRPr b="0" lang="es-MX" sz="1000" strike="noStrike" u="none">
-              <a:solidFill>
-                <a:srgbClr val="000000"/>
-              </a:solidFill>
-              <a:effectLst/>
-              <a:uFillTx/>
-              <a:latin typeface="Times New Roman"/>
-            </a:endParaRPr>
-          </a:p>
-        </p:txBody>
-      </p:sp>
-    </p:spTree>
-  </p:cSld>
-</p:sldLayout>
-</file>
-
-<file path=ppt/slideLayouts/slideLayout7.xml><?xml version="1.0" encoding="utf-8"?>
-<p:sldLayout xmlns:a="http://schemas.openxmlformats.org/drawingml/2006/main" xmlns:p="http://schemas.openxmlformats.org/presentationml/2006/main" xmlns:r="http://schemas.openxmlformats.org/officeDocument/2006/relationships" xmlns:p14="http://schemas.microsoft.com/office/powerpoint/2010/main" xmlns:p15="http://schemas.microsoft.com/office/powerpoint/2012/main" xmlns:mc="http://schemas.openxmlformats.org/markup-compatibility/2006" type="twoObj" preserve="1">
-  <p:cSld name="TITLE_AND_TWO_COLUMNS">
-    <p:bg>
-      <p:bgPr>
-        <a:solidFill>
-          <a:schemeClr val="lt1"/>
-        </a:solidFill>
-      </p:bgPr>
-    </p:bg>
-    <p:spTree>
-      <p:nvGrpSpPr>
-        <p:cNvPr id="1" name=""/>
-        <p:cNvGrpSpPr/>
-        <p:nvPr/>
-      </p:nvGrpSpPr>
-      <p:grpSpPr>
-        <a:xfrm>
-          <a:off x="0" y="0"/>
-          <a:ext cx="0" cy="0"/>
-          <a:chOff x="0" y="0"/>
-          <a:chExt cx="0" cy="0"/>
-        </a:xfrm>
-      </p:grpSpPr>
-      <p:sp>
-        <p:nvSpPr>
-          <p:cNvPr id="10" name="PlaceHolder 1"/>
-          <p:cNvSpPr>
-            <a:spLocks noGrp="1"/>
-          </p:cNvSpPr>
-          <p:nvPr>
-            <p:ph type="sldNum" idx="5"/>
-          </p:nvPr>
-        </p:nvSpPr>
-        <p:spPr>
-          <a:xfrm>
-            <a:off x="8472600" y="4663080"/>
-            <a:ext cx="548280" cy="393120"/>
-          </a:xfrm>
-          <a:prstGeom prst="rect">
-            <a:avLst/>
-          </a:prstGeom>
-          <a:noFill/>
-          <a:ln w="0">
-            <a:noFill/>
-          </a:ln>
-        </p:spPr>
-        <p:txBody>
-          <a:bodyPr lIns="91440" rIns="91440" tIns="91440" bIns="91440" anchor="ctr">
-            <a:normAutofit/>
-          </a:bodyPr>
-          <a:lstStyle>
-            <a:lvl1pPr indent="0" algn="r">
-              <a:lnSpc>
-                <a:spcPct val="100000"/>
-              </a:lnSpc>
-              <a:buNone/>
-              <a:tabLst>
-                <a:tab algn="l" pos="0"/>
-              </a:tabLst>
-              <a:defRPr b="0" lang="en" sz="1000" strike="noStrike" u="none">
-                <a:solidFill>
-                  <a:schemeClr val="dk2"/>
-                </a:solidFill>
-                <a:effectLst/>
-                <a:uFillTx/>
-                <a:latin typeface="Arial"/>
-                <a:ea typeface="Arial"/>
-              </a:defRPr>
-            </a:lvl1pPr>
-          </a:lstStyle>
-          <a:p>
-            <a:pPr indent="0" algn="r">
-              <a:lnSpc>
-                <a:spcPct val="100000"/>
-              </a:lnSpc>
-              <a:buNone/>
-              <a:tabLst>
-                <a:tab algn="l" pos="0"/>
-              </a:tabLst>
-            </a:pPr>
-            <a:fld id="{8F20E25E-C1FB-4BCC-AB35-1A6413FE9C99}" type="slidenum">
-              <a:rPr b="0" lang="en" sz="1000" strike="noStrike" u="none">
-                <a:solidFill>
-                  <a:schemeClr val="dk2"/>
-                </a:solidFill>
-                <a:effectLst/>
-                <a:uFillTx/>
-                <a:latin typeface="Arial"/>
-                <a:ea typeface="Arial"/>
-              </a:rPr>
-              <a:t>&lt;número&gt;</a:t>
-            </a:fld>
-            <a:endParaRPr b="0" lang="es-MX" sz="1000" strike="noStrike" u="none">
-              <a:solidFill>
-                <a:srgbClr val="000000"/>
-              </a:solidFill>
-              <a:effectLst/>
-              <a:uFillTx/>
-              <a:latin typeface="Times New Roman"/>
-            </a:endParaRPr>
-          </a:p>
-        </p:txBody>
-      </p:sp>
-    </p:spTree>
-  </p:cSld>
-</p:sldLayout>
-</file>
-
-<file path=ppt/slideLayouts/slideLayout8.xml><?xml version="1.0" encoding="utf-8"?>
-<p:sldLayout xmlns:a="http://schemas.openxmlformats.org/drawingml/2006/main" xmlns:p="http://schemas.openxmlformats.org/presentationml/2006/main" xmlns:r="http://schemas.openxmlformats.org/officeDocument/2006/relationships" xmlns:p14="http://schemas.microsoft.com/office/powerpoint/2010/main" xmlns:p15="http://schemas.microsoft.com/office/powerpoint/2012/main" xmlns:mc="http://schemas.openxmlformats.org/markup-compatibility/2006" type="titleOnly" preserve="1">
-  <p:cSld name="TITLE_ONLY">
-    <p:bg>
-      <p:bgPr>
-        <a:solidFill>
-          <a:schemeClr val="lt1"/>
-        </a:solidFill>
-      </p:bgPr>
-    </p:bg>
-    <p:spTree>
-      <p:nvGrpSpPr>
-        <p:cNvPr id="1" name=""/>
-        <p:cNvGrpSpPr/>
-        <p:nvPr/>
-      </p:nvGrpSpPr>
-      <p:grpSpPr>
-        <a:xfrm>
-          <a:off x="0" y="0"/>
-          <a:ext cx="0" cy="0"/>
-          <a:chOff x="0" y="0"/>
-          <a:chExt cx="0" cy="0"/>
-        </a:xfrm>
-      </p:grpSpPr>
-      <p:sp>
-        <p:nvSpPr>
-          <p:cNvPr id="11" name="PlaceHolder 1"/>
-          <p:cNvSpPr>
-            <a:spLocks noGrp="1"/>
-          </p:cNvSpPr>
-          <p:nvPr>
-            <p:ph type="sldNum" idx="6"/>
-          </p:nvPr>
-        </p:nvSpPr>
-        <p:spPr>
-          <a:xfrm>
-            <a:off x="8472600" y="4663080"/>
-            <a:ext cx="548280" cy="393120"/>
-          </a:xfrm>
-          <a:prstGeom prst="rect">
-            <a:avLst/>
-          </a:prstGeom>
-          <a:noFill/>
-          <a:ln w="0">
-            <a:noFill/>
-          </a:ln>
-        </p:spPr>
-        <p:txBody>
-          <a:bodyPr lIns="91440" rIns="91440" tIns="91440" bIns="91440" anchor="ctr">
-            <a:normAutofit/>
-          </a:bodyPr>
-          <a:lstStyle>
-            <a:lvl1pPr indent="0" algn="r">
-              <a:lnSpc>
-                <a:spcPct val="100000"/>
-              </a:lnSpc>
-              <a:buNone/>
-              <a:tabLst>
-                <a:tab algn="l" pos="0"/>
-              </a:tabLst>
-              <a:defRPr b="0" lang="en" sz="1000" strike="noStrike" u="none">
-                <a:solidFill>
-                  <a:schemeClr val="dk2"/>
-                </a:solidFill>
-                <a:effectLst/>
-                <a:uFillTx/>
-                <a:latin typeface="Arial"/>
-                <a:ea typeface="Arial"/>
-              </a:defRPr>
-            </a:lvl1pPr>
-          </a:lstStyle>
-          <a:p>
-            <a:pPr indent="0" algn="r">
-              <a:lnSpc>
-                <a:spcPct val="100000"/>
-              </a:lnSpc>
-              <a:buNone/>
-              <a:tabLst>
-                <a:tab algn="l" pos="0"/>
-              </a:tabLst>
-            </a:pPr>
-            <a:fld id="{2589A8EC-C361-4875-A84B-13D56660F2E3}" type="slidenum">
-              <a:rPr b="0" lang="en" sz="1000" strike="noStrike" u="none">
-                <a:solidFill>
-                  <a:schemeClr val="dk2"/>
-                </a:solidFill>
-                <a:effectLst/>
-                <a:uFillTx/>
-                <a:latin typeface="Arial"/>
-                <a:ea typeface="Arial"/>
-              </a:rPr>
-              <a:t>&lt;número&gt;</a:t>
-            </a:fld>
-            <a:endParaRPr b="0" lang="es-MX" sz="1000" strike="noStrike" u="none">
-              <a:solidFill>
-                <a:srgbClr val="000000"/>
-              </a:solidFill>
-              <a:effectLst/>
-              <a:uFillTx/>
-              <a:latin typeface="Times New Roman"/>
-            </a:endParaRPr>
-          </a:p>
-        </p:txBody>
-      </p:sp>
-    </p:spTree>
-  </p:cSld>
-</p:sldLayout>
-</file>
-
-<file path=ppt/slideLayouts/slideLayout9.xml><?xml version="1.0" encoding="utf-8"?>
-<p:sldLayout xmlns:a="http://schemas.openxmlformats.org/drawingml/2006/main" xmlns:p="http://schemas.openxmlformats.org/presentationml/2006/main" xmlns:r="http://schemas.openxmlformats.org/officeDocument/2006/relationships" xmlns:p14="http://schemas.microsoft.com/office/powerpoint/2010/main" xmlns:p15="http://schemas.microsoft.com/office/powerpoint/2012/main" xmlns:mc="http://schemas.openxmlformats.org/markup-compatibility/2006" type="blank" preserve="1">
-  <p:cSld name="ONE_COLUMN_TEXT">
-    <p:bg>
-      <p:bgPr>
-        <a:solidFill>
-          <a:schemeClr val="lt1"/>
-        </a:solidFill>
-      </p:bgPr>
-    </p:bg>
-    <p:spTree>
-      <p:nvGrpSpPr>
-        <p:cNvPr id="1" name=""/>
-        <p:cNvGrpSpPr/>
-        <p:nvPr/>
-      </p:nvGrpSpPr>
-      <p:grpSpPr>
-        <a:xfrm>
-          <a:off x="0" y="0"/>
-          <a:ext cx="0" cy="0"/>
-          <a:chOff x="0" y="0"/>
-          <a:chExt cx="0" cy="0"/>
-        </a:xfrm>
-      </p:grpSpPr>
-      <p:sp>
-        <p:nvSpPr>
-          <p:cNvPr id="12" name="PlaceHolder 1"/>
-          <p:cNvSpPr>
-            <a:spLocks noGrp="1"/>
-          </p:cNvSpPr>
-          <p:nvPr>
-            <p:ph type="sldNum" idx="7"/>
-          </p:nvPr>
-        </p:nvSpPr>
-        <p:spPr>
-          <a:xfrm>
-            <a:off x="8472600" y="4663080"/>
-            <a:ext cx="548280" cy="393120"/>
-          </a:xfrm>
-          <a:prstGeom prst="rect">
-            <a:avLst/>
-          </a:prstGeom>
-          <a:noFill/>
-          <a:ln w="0">
-            <a:noFill/>
-          </a:ln>
-        </p:spPr>
-        <p:txBody>
-          <a:bodyPr lIns="91440" rIns="91440" tIns="91440" bIns="91440" anchor="ctr">
-            <a:normAutofit/>
-          </a:bodyPr>
-          <a:lstStyle>
-            <a:lvl1pPr indent="0" algn="r">
-              <a:lnSpc>
-                <a:spcPct val="100000"/>
-              </a:lnSpc>
-              <a:buNone/>
-              <a:tabLst>
-                <a:tab algn="l" pos="0"/>
-              </a:tabLst>
-              <a:defRPr b="0" lang="en" sz="1000" strike="noStrike" u="none">
-                <a:solidFill>
-                  <a:schemeClr val="dk2"/>
-                </a:solidFill>
-                <a:effectLst/>
-                <a:uFillTx/>
-                <a:latin typeface="Arial"/>
-                <a:ea typeface="Arial"/>
-              </a:defRPr>
-            </a:lvl1pPr>
-          </a:lstStyle>
-          <a:p>
-            <a:pPr indent="0" algn="r">
-              <a:lnSpc>
-                <a:spcPct val="100000"/>
-              </a:lnSpc>
-              <a:buNone/>
-              <a:tabLst>
-                <a:tab algn="l" pos="0"/>
-              </a:tabLst>
-            </a:pPr>
-            <a:fld id="{2CC8BCF7-9027-45AA-BE4E-165670DDE14F}" type="slidenum">
-              <a:rPr b="0" lang="en" sz="1000" strike="noStrike" u="none">
-                <a:solidFill>
-                  <a:schemeClr val="dk2"/>
-                </a:solidFill>
-                <a:effectLst/>
-                <a:uFillTx/>
-                <a:latin typeface="Arial"/>
-                <a:ea typeface="Arial"/>
-              </a:rPr>
-              <a:t>&lt;número&gt;</a:t>
-            </a:fld>
-            <a:endParaRPr b="0" lang="es-MX" sz="1000" strike="noStrike" u="none">
-              <a:solidFill>
-                <a:srgbClr val="000000"/>
-              </a:solidFill>
-              <a:effectLst/>
-              <a:uFillTx/>
-              <a:latin typeface="Times New Roman"/>
-            </a:endParaRPr>
-          </a:p>
-        </p:txBody>
-      </p:sp>
     </p:spTree>
   </p:cSld>
 </p:sldLayout>
@@ -1837,7 +1891,7 @@
         <p:spPr>
           <a:xfrm>
             <a:off x="64080" y="638280"/>
-            <a:ext cx="8520120" cy="1666440"/>
+            <a:ext cx="8519760" cy="1666800"/>
           </a:xfrm>
           <a:prstGeom prst="rect">
             <a:avLst/>
@@ -1943,7 +1997,7 @@
         <p:spPr>
           <a:xfrm>
             <a:off x="228600" y="228600"/>
-            <a:ext cx="866520" cy="194040"/>
+            <a:ext cx="866160" cy="193680"/>
           </a:xfrm>
           <a:prstGeom prst="rect">
             <a:avLst/>
@@ -1957,13 +2011,13 @@
       <p:sp>
         <p:nvSpPr>
           <p:cNvPr id="18" name=""/>
-          <p:cNvSpPr txBox="1"/>
+          <p:cNvSpPr/>
           <p:nvPr/>
         </p:nvSpPr>
         <p:spPr>
           <a:xfrm>
             <a:off x="242640" y="4500000"/>
-            <a:ext cx="2997360" cy="413640"/>
+            <a:ext cx="2997000" cy="413280"/>
           </a:xfrm>
           <a:prstGeom prst="rect">
             <a:avLst/>
@@ -1973,12 +2027,23 @@
             <a:noFill/>
           </a:ln>
         </p:spPr>
+        <p:style>
+          <a:lnRef idx="0"/>
+          <a:fillRef idx="0"/>
+          <a:effectRef idx="0"/>
+          <a:fontRef idx="minor"/>
+        </p:style>
         <p:txBody>
           <a:bodyPr wrap="none" lIns="90000" rIns="90000" tIns="45000" bIns="45000" anchor="t">
             <a:spAutoFit/>
           </a:bodyPr>
           <a:p>
-            <a:fld id="{1BE02C9C-1787-4BE1-ABD0-51DAA368D0A7}" type="datetime3">
+            <a:pPr>
+              <a:lnSpc>
+                <a:spcPct val="100000"/>
+              </a:lnSpc>
+            </a:pPr>
+            <a:fld id="{EBB630F2-6418-4112-AA81-2C9F9FBF8C71}" type="datetime3">
               <a:rPr b="0" lang="es-MX" sz="2100" strike="noStrike" u="none">
                 <a:solidFill>
                   <a:srgbClr val="000000"/>
@@ -1987,7 +2052,7 @@
                 <a:uFillTx/>
                 <a:latin typeface="Inter SemiBold"/>
               </a:rPr>
-              <a:t>22 de agosto de 2025</a:t>
+              <a:t>23 de agosto de 2025</a:t>
             </a:fld>
             <a:endParaRPr b="0" lang="es-MX" sz="2100" strike="noStrike" u="none">
               <a:solidFill>
@@ -1995,7 +2060,7 @@
               </a:solidFill>
               <a:effectLst/>
               <a:uFillTx/>
-              <a:latin typeface="Times New Roman"/>
+              <a:latin typeface="Arial"/>
             </a:endParaRPr>
           </a:p>
         </p:txBody>
@@ -2050,7 +2115,7 @@
         <p:spPr>
           <a:xfrm>
             <a:off x="152280" y="2017800"/>
-            <a:ext cx="8520120" cy="2989440"/>
+            <a:ext cx="8519760" cy="2989080"/>
           </a:xfrm>
           <a:prstGeom prst="rect">
             <a:avLst/>
@@ -2349,7 +2414,7 @@
         <p:spPr>
           <a:xfrm>
             <a:off x="228600" y="228600"/>
-            <a:ext cx="866520" cy="194040"/>
+            <a:ext cx="866160" cy="193680"/>
           </a:xfrm>
           <a:prstGeom prst="rect">
             <a:avLst/>
@@ -2373,7 +2438,7 @@
         <p:spPr>
           <a:xfrm>
             <a:off x="96840" y="424800"/>
-            <a:ext cx="8520120" cy="800640"/>
+            <a:ext cx="8519760" cy="801000"/>
           </a:xfrm>
           <a:prstGeom prst="rect">
             <a:avLst/>
@@ -2466,7 +2531,7 @@
         <p:spPr>
           <a:xfrm>
             <a:off x="228600" y="1952280"/>
-            <a:ext cx="2724480" cy="2962080"/>
+            <a:ext cx="2724120" cy="2961720"/>
           </a:xfrm>
           <a:prstGeom prst="roundRect">
             <a:avLst>
@@ -2531,7 +2596,7 @@
         <p:spPr>
           <a:xfrm>
             <a:off x="3209400" y="1952280"/>
-            <a:ext cx="2724480" cy="2962080"/>
+            <a:ext cx="2724120" cy="2961720"/>
           </a:xfrm>
           <a:prstGeom prst="roundRect">
             <a:avLst>
@@ -2596,7 +2661,7 @@
         <p:spPr>
           <a:xfrm>
             <a:off x="6190560" y="1952280"/>
-            <a:ext cx="2724480" cy="2962080"/>
+            <a:ext cx="2724120" cy="2961720"/>
           </a:xfrm>
           <a:prstGeom prst="roundRect">
             <a:avLst>
@@ -2665,7 +2730,7 @@
         <p:spPr>
           <a:xfrm>
             <a:off x="228600" y="228600"/>
-            <a:ext cx="866520" cy="194040"/>
+            <a:ext cx="866160" cy="193680"/>
           </a:xfrm>
           <a:prstGeom prst="rect">
             <a:avLst/>
@@ -2689,7 +2754,7 @@
         <p:spPr>
           <a:xfrm>
             <a:off x="96840" y="424800"/>
-            <a:ext cx="8520120" cy="800640"/>
+            <a:ext cx="8519760" cy="801000"/>
           </a:xfrm>
           <a:prstGeom prst="rect">
             <a:avLst/>
@@ -2749,7 +2814,7 @@
         <p:spPr>
           <a:xfrm>
             <a:off x="424800" y="2191320"/>
-            <a:ext cx="474120" cy="760320"/>
+            <a:ext cx="473760" cy="759960"/>
           </a:xfrm>
           <a:prstGeom prst="rect">
             <a:avLst/>
@@ -2773,7 +2838,7 @@
         <p:spPr>
           <a:xfrm>
             <a:off x="3468960" y="2191320"/>
-            <a:ext cx="474120" cy="760320"/>
+            <a:ext cx="473760" cy="759960"/>
           </a:xfrm>
           <a:prstGeom prst="rect">
             <a:avLst/>
@@ -2797,7 +2862,7 @@
         <p:spPr>
           <a:xfrm>
             <a:off x="6407280" y="2191320"/>
-            <a:ext cx="474120" cy="760320"/>
+            <a:ext cx="473760" cy="759960"/>
           </a:xfrm>
           <a:prstGeom prst="rect">
             <a:avLst/>
@@ -2858,7 +2923,7 @@
         <p:spPr>
           <a:xfrm>
             <a:off x="96840" y="2386440"/>
-            <a:ext cx="8520120" cy="2527920"/>
+            <a:ext cx="8519760" cy="2527560"/>
           </a:xfrm>
           <a:prstGeom prst="rect">
             <a:avLst/>
@@ -2896,7 +2961,7 @@
             </a:r>
             <a:endParaRPr b="0" lang="es-MX" sz="4800" strike="noStrike" u="none">
               <a:solidFill>
-                <a:srgbClr val="000000"/>
+                <a:srgbClr val="ffffff"/>
               </a:solidFill>
               <a:effectLst/>
               <a:uFillTx/>
@@ -2918,7 +2983,7 @@
         <p:spPr>
           <a:xfrm>
             <a:off x="228600" y="228600"/>
-            <a:ext cx="868320" cy="191520"/>
+            <a:ext cx="867960" cy="191160"/>
           </a:xfrm>
           <a:prstGeom prst="rect">
             <a:avLst/>
@@ -2975,7 +3040,7 @@
         <p:spPr>
           <a:xfrm>
             <a:off x="228600" y="1952280"/>
-            <a:ext cx="2724480" cy="2962080"/>
+            <a:ext cx="2724120" cy="2961720"/>
           </a:xfrm>
           <a:prstGeom prst="roundRect">
             <a:avLst>
@@ -3040,7 +3105,7 @@
         <p:spPr>
           <a:xfrm>
             <a:off x="3209400" y="1952280"/>
-            <a:ext cx="2724480" cy="2962080"/>
+            <a:ext cx="2724120" cy="2961720"/>
           </a:xfrm>
           <a:prstGeom prst="roundRect">
             <a:avLst>
@@ -3105,7 +3170,7 @@
         <p:spPr>
           <a:xfrm>
             <a:off x="6190560" y="1952280"/>
-            <a:ext cx="2724480" cy="2962080"/>
+            <a:ext cx="2724120" cy="2961720"/>
           </a:xfrm>
           <a:prstGeom prst="roundRect">
             <a:avLst>
@@ -3139,7 +3204,7 @@
               </a:tabLst>
             </a:pPr>
             <a:r>
-              <a:rPr b="0" lang="es-CO" sz="1800" strike="noStrike" u="none">
+              <a:rPr b="0" i="1" lang="es-CO" sz="1800" strike="noStrike" u="none">
                 <a:solidFill>
                   <a:srgbClr val="000000"/>
                 </a:solidFill>
@@ -3148,9 +3213,9 @@
                 <a:latin typeface="Arial"/>
                 <a:ea typeface="Arial"/>
               </a:rPr>
-              <a:t>¿Qué pasaría si quiero gráficas un df muy grande?</a:t>
+              <a:t>¿Que herramientas tenemos para examinar mejor nuestros datos?</a:t>
             </a:r>
-            <a:endParaRPr b="0" lang="es-MX" sz="1800" strike="noStrike" u="none">
+            <a:endParaRPr b="0" i="1" lang="es-MX" sz="1800" strike="noStrike" u="none">
               <a:solidFill>
                 <a:srgbClr val="000000"/>
               </a:solidFill>
@@ -3174,7 +3239,7 @@
         <p:spPr>
           <a:xfrm>
             <a:off x="228600" y="228600"/>
-            <a:ext cx="866520" cy="194040"/>
+            <a:ext cx="866160" cy="193680"/>
           </a:xfrm>
           <a:prstGeom prst="rect">
             <a:avLst/>
@@ -3198,7 +3263,7 @@
         <p:spPr>
           <a:xfrm>
             <a:off x="96840" y="424800"/>
-            <a:ext cx="8520120" cy="800640"/>
+            <a:ext cx="8519760" cy="801000"/>
           </a:xfrm>
           <a:prstGeom prst="rect">
             <a:avLst/>
@@ -3258,7 +3323,7 @@
         <p:spPr>
           <a:xfrm>
             <a:off x="424800" y="2191320"/>
-            <a:ext cx="474120" cy="760320"/>
+            <a:ext cx="473760" cy="759960"/>
           </a:xfrm>
           <a:prstGeom prst="rect">
             <a:avLst/>
@@ -3282,7 +3347,7 @@
         <p:spPr>
           <a:xfrm>
             <a:off x="3468960" y="2191320"/>
-            <a:ext cx="474120" cy="760320"/>
+            <a:ext cx="473760" cy="759960"/>
           </a:xfrm>
           <a:prstGeom prst="rect">
             <a:avLst/>
@@ -3306,7 +3371,7 @@
         <p:spPr>
           <a:xfrm>
             <a:off x="6407280" y="2191320"/>
-            <a:ext cx="474120" cy="760320"/>
+            <a:ext cx="473760" cy="759960"/>
           </a:xfrm>
           <a:prstGeom prst="rect">
             <a:avLst/>
@@ -3367,7 +3432,7 @@
         <p:spPr>
           <a:xfrm>
             <a:off x="228600" y="228600"/>
-            <a:ext cx="866520" cy="194040"/>
+            <a:ext cx="866160" cy="193680"/>
           </a:xfrm>
           <a:prstGeom prst="rect">
             <a:avLst/>
@@ -3391,7 +3456,7 @@
         <p:spPr>
           <a:xfrm>
             <a:off x="322920" y="817560"/>
-            <a:ext cx="6138000" cy="2677680"/>
+            <a:ext cx="6137640" cy="2678040"/>
           </a:xfrm>
           <a:prstGeom prst="rect">
             <a:avLst/>
@@ -3488,7 +3553,7 @@
         <p:spPr>
           <a:xfrm>
             <a:off x="311760" y="1914120"/>
-            <a:ext cx="8520120" cy="923760"/>
+            <a:ext cx="8519760" cy="924120"/>
           </a:xfrm>
           <a:prstGeom prst="rect">
             <a:avLst/>
@@ -3548,7 +3613,7 @@
         <p:spPr>
           <a:xfrm>
             <a:off x="3642120" y="2053080"/>
-            <a:ext cx="645120" cy="644760"/>
+            <a:ext cx="644760" cy="644400"/>
           </a:xfrm>
           <a:prstGeom prst="rect">
             <a:avLst/>
@@ -3572,7 +3637,7 @@
         <p:spPr>
           <a:xfrm>
             <a:off x="4138560" y="228600"/>
-            <a:ext cx="866520" cy="194040"/>
+            <a:ext cx="866160" cy="193680"/>
           </a:xfrm>
           <a:prstGeom prst="rect">
             <a:avLst/>

</xml_diff>